<commit_message>
Tag code Try-It items in Lesson 2
Audited the joystick-control deck against its lesson doc — code coverage
was already complete, no missing slides. Tag all three Try-It items
(slow mode, square the input, print raw vs. deadbanded) with the WRITE
CODE pill in the deck and a bold Code lead-in in the lesson doc, since
each involves writing real code rather than just running or observing
something.
</commit_message>
<xml_diff>
--- a/docs/presentations/v3/02-joystick-control.pptx
+++ b/docs/presentations/v3/02-joystick-control.pptx
@@ -6753,7 +6753,7 @@
         <p:spPr>
           <a:xfrm>
             <a:off x="1600200" y="1691640"/>
-            <a:ext cx="4023360" cy="457200"/>
+            <a:ext cx="2606040" cy="457200"/>
           </a:xfrm>
           <a:prstGeom prst="rect">
             <a:avLst/>
@@ -6788,7 +6788,68 @@
       </p:sp>
       <p:sp>
         <p:nvSpPr>
-          <p:cNvPr id="10" name="Text 7"/>
+          <p:cNvPr id="10" name="Shape 7"/>
+          <p:cNvSpPr/>
+          <p:nvPr/>
+        </p:nvSpPr>
+        <p:spPr>
+          <a:xfrm>
+            <a:off x="4206240" y="1773936"/>
+            <a:ext cx="1417320" cy="292608"/>
+          </a:xfrm>
+          <a:prstGeom prst="roundRect">
+            <a:avLst>
+              <a:gd name="adj" fmla="val 18750"/>
+            </a:avLst>
+          </a:prstGeom>
+          <a:solidFill>
+            <a:srgbClr val="FF5010"/>
+          </a:solidFill>
+          <a:ln/>
+        </p:spPr>
+      </p:sp>
+      <p:sp>
+        <p:nvSpPr>
+          <p:cNvPr id="11" name="Text 8"/>
+          <p:cNvSpPr/>
+          <p:nvPr/>
+        </p:nvSpPr>
+        <p:spPr>
+          <a:xfrm>
+            <a:off x="4206240" y="1773936"/>
+            <a:ext cx="1417320" cy="292608"/>
+          </a:xfrm>
+          <a:prstGeom prst="rect">
+            <a:avLst/>
+          </a:prstGeom>
+          <a:noFill/>
+          <a:ln/>
+        </p:spPr>
+        <p:txBody>
+          <a:bodyPr wrap="square" lIns="0" tIns="0" rIns="0" bIns="0" rtlCol="0" anchor="ctr"/>
+          <a:lstStyle/>
+          <a:p>
+            <a:pPr algn="ctr" indent="0" marL="0">
+              <a:buNone/>
+            </a:pPr>
+            <a:r>
+              <a:rPr lang="en-US" sz="1200" b="1" spc="50" kern="0" dirty="0">
+                <a:solidFill>
+                  <a:srgbClr val="0B1F3A"/>
+                </a:solidFill>
+                <a:latin typeface="Calibri" pitchFamily="34" charset="0"/>
+                <a:ea typeface="Calibri" pitchFamily="34" charset="-122"/>
+                <a:cs typeface="Calibri" pitchFamily="34" charset="-120"/>
+              </a:rPr>
+              <a:t>WRITE CODE</a:t>
+            </a:r>
+            <a:endParaRPr lang="en-US" sz="1200" dirty="0"/>
+          </a:p>
+        </p:txBody>
+      </p:sp>
+      <p:sp>
+        <p:nvSpPr>
+          <p:cNvPr id="12" name="Text 9"/>
           <p:cNvSpPr/>
           <p:nvPr/>
         </p:nvSpPr>
@@ -6830,7 +6891,7 @@
       </p:sp>
       <p:sp>
         <p:nvSpPr>
-          <p:cNvPr id="11" name="Shape 8"/>
+          <p:cNvPr id="13" name="Shape 10"/>
           <p:cNvSpPr/>
           <p:nvPr/>
         </p:nvSpPr>
@@ -6852,7 +6913,7 @@
       </p:sp>
       <p:sp>
         <p:nvSpPr>
-          <p:cNvPr id="12" name="Shape 9"/>
+          <p:cNvPr id="14" name="Shape 11"/>
           <p:cNvSpPr/>
           <p:nvPr/>
         </p:nvSpPr>
@@ -6872,7 +6933,7 @@
       </p:sp>
       <p:sp>
         <p:nvSpPr>
-          <p:cNvPr id="13" name="Text 10"/>
+          <p:cNvPr id="15" name="Text 12"/>
           <p:cNvSpPr/>
           <p:nvPr/>
         </p:nvSpPr>
@@ -6911,14 +6972,14 @@
       </p:sp>
       <p:sp>
         <p:nvSpPr>
-          <p:cNvPr id="14" name="Text 11"/>
+          <p:cNvPr id="16" name="Text 13"/>
           <p:cNvSpPr/>
           <p:nvPr/>
         </p:nvSpPr>
         <p:spPr>
           <a:xfrm>
             <a:off x="7178040" y="1691640"/>
-            <a:ext cx="4023360" cy="457200"/>
+            <a:ext cx="2606040" cy="457200"/>
           </a:xfrm>
           <a:prstGeom prst="rect">
             <a:avLst/>
@@ -6953,7 +7014,68 @@
       </p:sp>
       <p:sp>
         <p:nvSpPr>
-          <p:cNvPr id="15" name="Text 12"/>
+          <p:cNvPr id="17" name="Shape 14"/>
+          <p:cNvSpPr/>
+          <p:nvPr/>
+        </p:nvSpPr>
+        <p:spPr>
+          <a:xfrm>
+            <a:off x="9784080" y="1773936"/>
+            <a:ext cx="1417320" cy="292608"/>
+          </a:xfrm>
+          <a:prstGeom prst="roundRect">
+            <a:avLst>
+              <a:gd name="adj" fmla="val 18750"/>
+            </a:avLst>
+          </a:prstGeom>
+          <a:solidFill>
+            <a:srgbClr val="FF5010"/>
+          </a:solidFill>
+          <a:ln/>
+        </p:spPr>
+      </p:sp>
+      <p:sp>
+        <p:nvSpPr>
+          <p:cNvPr id="18" name="Text 15"/>
+          <p:cNvSpPr/>
+          <p:nvPr/>
+        </p:nvSpPr>
+        <p:spPr>
+          <a:xfrm>
+            <a:off x="9784080" y="1773936"/>
+            <a:ext cx="1417320" cy="292608"/>
+          </a:xfrm>
+          <a:prstGeom prst="rect">
+            <a:avLst/>
+          </a:prstGeom>
+          <a:noFill/>
+          <a:ln/>
+        </p:spPr>
+        <p:txBody>
+          <a:bodyPr wrap="square" lIns="0" tIns="0" rIns="0" bIns="0" rtlCol="0" anchor="ctr"/>
+          <a:lstStyle/>
+          <a:p>
+            <a:pPr algn="ctr" indent="0" marL="0">
+              <a:buNone/>
+            </a:pPr>
+            <a:r>
+              <a:rPr lang="en-US" sz="1200" b="1" spc="50" kern="0" dirty="0">
+                <a:solidFill>
+                  <a:srgbClr val="0B1F3A"/>
+                </a:solidFill>
+                <a:latin typeface="Calibri" pitchFamily="34" charset="0"/>
+                <a:ea typeface="Calibri" pitchFamily="34" charset="-122"/>
+                <a:cs typeface="Calibri" pitchFamily="34" charset="-120"/>
+              </a:rPr>
+              <a:t>WRITE CODE</a:t>
+            </a:r>
+            <a:endParaRPr lang="en-US" sz="1200" dirty="0"/>
+          </a:p>
+        </p:txBody>
+      </p:sp>
+      <p:sp>
+        <p:nvSpPr>
+          <p:cNvPr id="19" name="Text 16"/>
           <p:cNvSpPr/>
           <p:nvPr/>
         </p:nvSpPr>
@@ -6995,7 +7117,7 @@
       </p:sp>
       <p:sp>
         <p:nvSpPr>
-          <p:cNvPr id="16" name="Shape 13"/>
+          <p:cNvPr id="20" name="Shape 17"/>
           <p:cNvSpPr/>
           <p:nvPr/>
         </p:nvSpPr>
@@ -7017,7 +7139,7 @@
       </p:sp>
       <p:sp>
         <p:nvSpPr>
-          <p:cNvPr id="17" name="Shape 14"/>
+          <p:cNvPr id="21" name="Shape 18"/>
           <p:cNvSpPr/>
           <p:nvPr/>
         </p:nvSpPr>
@@ -7037,7 +7159,7 @@
       </p:sp>
       <p:sp>
         <p:nvSpPr>
-          <p:cNvPr id="18" name="Text 15"/>
+          <p:cNvPr id="22" name="Text 19"/>
           <p:cNvSpPr/>
           <p:nvPr/>
         </p:nvSpPr>
@@ -7076,14 +7198,14 @@
       </p:sp>
       <p:sp>
         <p:nvSpPr>
-          <p:cNvPr id="19" name="Text 16"/>
+          <p:cNvPr id="23" name="Text 20"/>
           <p:cNvSpPr/>
           <p:nvPr/>
         </p:nvSpPr>
         <p:spPr>
           <a:xfrm>
             <a:off x="1600200" y="4251960"/>
-            <a:ext cx="4023360" cy="457200"/>
+            <a:ext cx="2606040" cy="457200"/>
           </a:xfrm>
           <a:prstGeom prst="rect">
             <a:avLst/>
@@ -7118,7 +7240,68 @@
       </p:sp>
       <p:sp>
         <p:nvSpPr>
-          <p:cNvPr id="20" name="Text 17"/>
+          <p:cNvPr id="24" name="Shape 21"/>
+          <p:cNvSpPr/>
+          <p:nvPr/>
+        </p:nvSpPr>
+        <p:spPr>
+          <a:xfrm>
+            <a:off x="4206240" y="4334256"/>
+            <a:ext cx="1417320" cy="292608"/>
+          </a:xfrm>
+          <a:prstGeom prst="roundRect">
+            <a:avLst>
+              <a:gd name="adj" fmla="val 18750"/>
+            </a:avLst>
+          </a:prstGeom>
+          <a:solidFill>
+            <a:srgbClr val="FF5010"/>
+          </a:solidFill>
+          <a:ln/>
+        </p:spPr>
+      </p:sp>
+      <p:sp>
+        <p:nvSpPr>
+          <p:cNvPr id="25" name="Text 22"/>
+          <p:cNvSpPr/>
+          <p:nvPr/>
+        </p:nvSpPr>
+        <p:spPr>
+          <a:xfrm>
+            <a:off x="4206240" y="4334256"/>
+            <a:ext cx="1417320" cy="292608"/>
+          </a:xfrm>
+          <a:prstGeom prst="rect">
+            <a:avLst/>
+          </a:prstGeom>
+          <a:noFill/>
+          <a:ln/>
+        </p:spPr>
+        <p:txBody>
+          <a:bodyPr wrap="square" lIns="0" tIns="0" rIns="0" bIns="0" rtlCol="0" anchor="ctr"/>
+          <a:lstStyle/>
+          <a:p>
+            <a:pPr algn="ctr" indent="0" marL="0">
+              <a:buNone/>
+            </a:pPr>
+            <a:r>
+              <a:rPr lang="en-US" sz="1200" b="1" spc="50" kern="0" dirty="0">
+                <a:solidFill>
+                  <a:srgbClr val="0B1F3A"/>
+                </a:solidFill>
+                <a:latin typeface="Calibri" pitchFamily="34" charset="0"/>
+                <a:ea typeface="Calibri" pitchFamily="34" charset="-122"/>
+                <a:cs typeface="Calibri" pitchFamily="34" charset="-120"/>
+              </a:rPr>
+              <a:t>WRITE CODE</a:t>
+            </a:r>
+            <a:endParaRPr lang="en-US" sz="1200" dirty="0"/>
+          </a:p>
+        </p:txBody>
+      </p:sp>
+      <p:sp>
+        <p:nvSpPr>
+          <p:cNvPr id="26" name="Text 23"/>
           <p:cNvSpPr/>
           <p:nvPr/>
         </p:nvSpPr>
@@ -7160,7 +7343,7 @@
       </p:sp>
       <p:sp>
         <p:nvSpPr>
-          <p:cNvPr id="21" name="Text 18"/>
+          <p:cNvPr id="27" name="Text 24"/>
           <p:cNvSpPr/>
           <p:nvPr/>
         </p:nvSpPr>
@@ -7199,7 +7382,7 @@
       </p:sp>
       <p:sp>
         <p:nvSpPr>
-          <p:cNvPr id="22" name="Text 19"/>
+          <p:cNvPr id="28" name="Text 25"/>
           <p:cNvSpPr/>
           <p:nvPr/>
         </p:nvSpPr>
@@ -7238,7 +7421,7 @@
       </p:sp>
       <p:pic>
         <p:nvPicPr>
-          <p:cNvPr id="23" name="Image 1" descr="/home/user/BasicRobotLessons/docs/presentations/v3/template/assets/logo/team5010-logo-onnavy.png">    </p:cNvPr>
+          <p:cNvPr id="29" name="Image 1" descr="/home/user/BasicRobotLessons/docs/presentations/v3/template/assets/logo/team5010-logo-onnavy.png">    </p:cNvPr>
           <p:cNvPicPr>
             <a:picLocks noChangeAspect="1"/>
           </p:cNvPicPr>

</xml_diff>